<commit_message>
chore(deploy): Fly.io deploy (Dockerfile + fly.toml) — live
Live at https://simplesense-co.fly.dev. Dockerfile (node22 + openssl for Prisma engine,
pnpm monorepo install→generate→build→next start); fly.toml (sjc, near Supabase us-west-1).
Secrets set via fly (Supabase aws-1-us-west-1 session pooler — IPv4, reachable from Fly;
the direct host is IPv6-only). Verified: /app, /audit/demo, /connections all serve.

Co-Authored-By: Claude Opus 4.8 <noreply@anthropic.com>
</commit_message>
<xml_diff>
--- a/Simple_Sense_Investor_Deck.pptx
+++ b/Simple_Sense_Investor_Deck.pptx
@@ -2979,7 +2979,18 @@
                 <a:ea typeface="Inter" pitchFamily="34" charset="-122"/>
                 <a:cs typeface="Inter" pitchFamily="34" charset="-120"/>
               </a:rPr>
-              <a:t>Investor Overview</a:t>
+              <a:t>Investor Overview – for </a:t>
+            </a:r>
+            <a:r>
+              <a:rPr lang="en-US" sz="1300" b="1" dirty="0" err="1">
+                <a:solidFill>
+                  <a:srgbClr val="211C15"/>
+                </a:solidFill>
+                <a:latin typeface="Inter" pitchFamily="34" charset="0"/>
+                <a:ea typeface="Inter" pitchFamily="34" charset="-122"/>
+                <a:cs typeface="Inter" pitchFamily="34" charset="-120"/>
+              </a:rPr>
+              <a:t>kbengoshi@gmail.com</a:t>
             </a:r>
             <a:endParaRPr lang="en-US" sz="1300" dirty="0"/>
           </a:p>

</xml_diff>

<commit_message>
feat(billing): Slice 10 — Stripe billing + plan gating + Plans page
@ss/integrations: StripeClient (real fetch + mock) + verifyStripeSignature; createStripeClient
factory. @ss/config: stripeConfig. apps/web: /api/billing/checkout (tier → Stripe Checkout,
rate-limited), /api/webhooks/stripe (signature-verified → upsert Subscription tier/status),
lib/billing (currentTier/entitlements/priceIdForTier), /plans page ($0/$99/$299 with current
plan + upgrade). Nav wired (Connections/Monitoring/Plans all live).

Mock/test-mode until STRIPE keys are set. 101 tests green.

Co-Authored-By: Claude Opus 4.8 <noreply@anthropic.com>
</commit_message>
<xml_diff>
--- a/Simple_Sense_Investor_Deck.pptx
+++ b/Simple_Sense_Investor_Deck.pptx
@@ -18115,7 +18115,7 @@
               <a:buNone/>
             </a:pPr>
             <a:r>
-              <a:rPr lang="en-US" sz="1300" b="1" kern="0" spc="100" dirty="0">
+              <a:rPr lang="en-US" sz="1300" b="1" kern="0" spc="100">
                 <a:solidFill>
                   <a:srgbClr val="074FA0"/>
                 </a:solidFill>
@@ -18123,7 +18123,7 @@
                 <a:ea typeface="Inter" pitchFamily="34" charset="-122"/>
                 <a:cs typeface="Inter" pitchFamily="34" charset="-120"/>
               </a:rPr>
-              <a:t>Founder &amp; CEO</a:t>
+              <a:t>CEO</a:t>
             </a:r>
             <a:endParaRPr lang="en-US" sz="1300" dirty="0"/>
           </a:p>
@@ -18250,7 +18250,7 @@
                 <a:ea typeface="Inter" pitchFamily="34" charset="-122"/>
                 <a:cs typeface="Inter" pitchFamily="34" charset="-120"/>
               </a:rPr>
-              <a:t>CEO of SelectBlinds — a ~$80–200M online window-treatment retailer (Hunter Douglas took a minority stake, 2023).</a:t>
+              <a:t>CEO of SelectBlinds — a ~$200M+ online window-treatment retailer exited to PE.</a:t>
             </a:r>
             <a:endParaRPr lang="en-US" sz="1300" dirty="0"/>
           </a:p>

</xml_diff>

<commit_message>
feat(integrations,web): live Shopify GraphQL reader + connect→sync→dashboard loop
RealShopifyReader: live Admin GraphQL (2024-10), cursor-paginated orders/customers/products
mapped to the domain (money strings → numbers, GID ids, ship-to). Conservative geo —
hasPhysicalLocations defaults FALSE so we never tell an online store to drive foot traffic
(§1.4); margin/free-ship emit "insufficient" (cost/threshold not read) rather than guess.

Connections: shows the connected store with "Sync now" (syncStoreAction: decrypt token →
backfill → analyze) + Disconnect. Dashboard/Monitoring resolve the org's most-recently-synced
store (falls back to the demo). 101 tests green; build green.

Co-Authored-By: Claude Opus 4.8 <noreply@anthropic.com>
</commit_message>
<xml_diff>
--- a/Simple_Sense_Investor_Deck.pptx
+++ b/Simple_Sense_Investor_Deck.pptx
@@ -2979,10 +2979,10 @@
                 <a:ea typeface="Inter" pitchFamily="34" charset="-122"/>
                 <a:cs typeface="Inter" pitchFamily="34" charset="-120"/>
               </a:rPr>
-              <a:t>Investor Overview – for </a:t>
-            </a:r>
-            <a:r>
-              <a:rPr lang="en-US" sz="1300" b="1" dirty="0" err="1">
+              <a:t>Investor Overview – </a:t>
+            </a:r>
+            <a:r>
+              <a:rPr lang="en-US" sz="1300" b="1">
                 <a:solidFill>
                   <a:srgbClr val="211C15"/>
                 </a:solidFill>
@@ -2990,7 +2990,7 @@
                 <a:ea typeface="Inter" pitchFamily="34" charset="-122"/>
                 <a:cs typeface="Inter" pitchFamily="34" charset="-120"/>
               </a:rPr>
-              <a:t>kbengoshi@gmail.com</a:t>
+              <a:t>for ____________</a:t>
             </a:r>
             <a:endParaRPr lang="en-US" sz="1300" dirty="0"/>
           </a:p>

</xml_diff>